<commit_message>
feat(assets): add new presentation and image file
- Added 02-Microsoft 365 Copilot Cowork.pptx to assets/pptx
- Added image.png to instructions
</commit_message>
<xml_diff>
--- a/assets/pptx/02-Microsoft 365 Copilot Cowork.pptx
+++ b/assets/pptx/02-Microsoft 365 Copilot Cowork.pptx
@@ -8181,8 +8181,8 @@
         </p:nvSpPr>
         <p:spPr>
           <a:xfrm>
-            <a:off x="257299" y="0"/>
-            <a:ext cx="11590317" cy="0"/>
+            <a:off x="457200" y="1417320"/>
+            <a:ext cx="11274552" cy="2743200"/>
           </a:xfrm>
         </p:spPr>
         <p:txBody>
@@ -8232,6 +8232,443 @@
             <a:r>
               <a:rPr lang="en-US" dirty="0"/>
               <a:t>All surface in the same panel and activate the same way, from the task</a:t>
+            </a:r>
+          </a:p>
+        </p:txBody>
+      </p:sp>
+      <p:sp>
+        <p:nvSpPr>
+          <p:cNvPr id="4" name="Rounded Rectangle 3"/>
+          <p:cNvSpPr/>
+          <p:nvPr/>
+        </p:nvSpPr>
+        <p:spPr>
+          <a:xfrm>
+            <a:off x="502920" y="4572000"/>
+            <a:ext cx="1929993" cy="1051560"/>
+          </a:xfrm>
+          <a:prstGeom prst="roundRect">
+            <a:avLst/>
+          </a:prstGeom>
+          <a:solidFill>
+            <a:srgbClr val="2B579A"/>
+          </a:solidFill>
+          <a:ln>
+            <a:solidFill>
+              <a:srgbClr val="2B579A"/>
+            </a:solidFill>
+          </a:ln>
+        </p:spPr>
+        <p:style>
+          <a:lnRef idx="1">
+            <a:schemeClr val="accent1"/>
+          </a:lnRef>
+          <a:fillRef idx="3">
+            <a:schemeClr val="accent1"/>
+          </a:fillRef>
+          <a:effectRef idx="2">
+            <a:schemeClr val="accent1"/>
+          </a:effectRef>
+          <a:fontRef idx="minor">
+            <a:schemeClr val="lt1"/>
+          </a:fontRef>
+        </p:style>
+        <p:txBody>
+          <a:bodyPr rtlCol="0" anchor="ctr" wrap="square" tIns="0" bIns="0"/>
+          <a:lstStyle/>
+          <a:p>
+            <a:pPr algn="ctr"/>
+            <a:r>
+              <a:rPr sz="1300" b="1">
+                <a:solidFill>
+                  <a:srgbClr val="FFFFFF"/>
+                </a:solidFill>
+              </a:rPr>
+              <a:t>Built-in skills</a:t>
+            </a:r>
+          </a:p>
+        </p:txBody>
+      </p:sp>
+      <p:sp>
+        <p:nvSpPr>
+          <p:cNvPr id="5" name="Right Arrow 4"/>
+          <p:cNvSpPr/>
+          <p:nvPr/>
+        </p:nvSpPr>
+        <p:spPr>
+          <a:xfrm>
+            <a:off x="2487777" y="4937760"/>
+            <a:ext cx="274320" cy="310896"/>
+          </a:xfrm>
+          <a:prstGeom prst="rightArrow">
+            <a:avLst/>
+          </a:prstGeom>
+          <a:solidFill>
+            <a:srgbClr val="8A8A8A"/>
+          </a:solidFill>
+          <a:ln>
+            <a:noFill/>
+          </a:ln>
+        </p:spPr>
+        <p:style>
+          <a:lnRef idx="1">
+            <a:schemeClr val="accent1"/>
+          </a:lnRef>
+          <a:fillRef idx="3">
+            <a:schemeClr val="accent1"/>
+          </a:fillRef>
+          <a:effectRef idx="2">
+            <a:schemeClr val="accent1"/>
+          </a:effectRef>
+          <a:fontRef idx="minor">
+            <a:schemeClr val="lt1"/>
+          </a:fontRef>
+        </p:style>
+        <p:txBody>
+          <a:bodyPr rtlCol="0" anchor="ctr"/>
+          <a:lstStyle/>
+          <a:p>
+            <a:pPr algn="ctr"/>
+          </a:p>
+        </p:txBody>
+      </p:sp>
+      <p:sp>
+        <p:nvSpPr>
+          <p:cNvPr id="6" name="Rounded Rectangle 5"/>
+          <p:cNvSpPr/>
+          <p:nvPr/>
+        </p:nvSpPr>
+        <p:spPr>
+          <a:xfrm>
+            <a:off x="2816961" y="4572000"/>
+            <a:ext cx="1929993" cy="1051560"/>
+          </a:xfrm>
+          <a:prstGeom prst="roundRect">
+            <a:avLst/>
+          </a:prstGeom>
+          <a:solidFill>
+            <a:srgbClr val="2B579A"/>
+          </a:solidFill>
+          <a:ln>
+            <a:solidFill>
+              <a:srgbClr val="2B579A"/>
+            </a:solidFill>
+          </a:ln>
+        </p:spPr>
+        <p:style>
+          <a:lnRef idx="1">
+            <a:schemeClr val="accent1"/>
+          </a:lnRef>
+          <a:fillRef idx="3">
+            <a:schemeClr val="accent1"/>
+          </a:fillRef>
+          <a:effectRef idx="2">
+            <a:schemeClr val="accent1"/>
+          </a:effectRef>
+          <a:fontRef idx="minor">
+            <a:schemeClr val="lt1"/>
+          </a:fontRef>
+        </p:style>
+        <p:txBody>
+          <a:bodyPr rtlCol="0" anchor="ctr" wrap="square" tIns="0" bIns="0"/>
+          <a:lstStyle/>
+          <a:p>
+            <a:pPr algn="ctr"/>
+            <a:r>
+              <a:rPr sz="1300" b="1">
+                <a:solidFill>
+                  <a:srgbClr val="FFFFFF"/>
+                </a:solidFill>
+              </a:rPr>
+              <a:t>Custom skills</a:t>
+            </a:r>
+          </a:p>
+        </p:txBody>
+      </p:sp>
+      <p:sp>
+        <p:nvSpPr>
+          <p:cNvPr id="7" name="Right Arrow 6"/>
+          <p:cNvSpPr/>
+          <p:nvPr/>
+        </p:nvSpPr>
+        <p:spPr>
+          <a:xfrm>
+            <a:off x="4801818" y="4937760"/>
+            <a:ext cx="274320" cy="310896"/>
+          </a:xfrm>
+          <a:prstGeom prst="rightArrow">
+            <a:avLst/>
+          </a:prstGeom>
+          <a:solidFill>
+            <a:srgbClr val="8A8A8A"/>
+          </a:solidFill>
+          <a:ln>
+            <a:noFill/>
+          </a:ln>
+        </p:spPr>
+        <p:style>
+          <a:lnRef idx="1">
+            <a:schemeClr val="accent1"/>
+          </a:lnRef>
+          <a:fillRef idx="3">
+            <a:schemeClr val="accent1"/>
+          </a:fillRef>
+          <a:effectRef idx="2">
+            <a:schemeClr val="accent1"/>
+          </a:effectRef>
+          <a:fontRef idx="minor">
+            <a:schemeClr val="lt1"/>
+          </a:fontRef>
+        </p:style>
+        <p:txBody>
+          <a:bodyPr rtlCol="0" anchor="ctr"/>
+          <a:lstStyle/>
+          <a:p>
+            <a:pPr algn="ctr"/>
+          </a:p>
+        </p:txBody>
+      </p:sp>
+      <p:sp>
+        <p:nvSpPr>
+          <p:cNvPr id="8" name="Rounded Rectangle 7"/>
+          <p:cNvSpPr/>
+          <p:nvPr/>
+        </p:nvSpPr>
+        <p:spPr>
+          <a:xfrm>
+            <a:off x="5131002" y="4572000"/>
+            <a:ext cx="1929993" cy="1051560"/>
+          </a:xfrm>
+          <a:prstGeom prst="roundRect">
+            <a:avLst/>
+          </a:prstGeom>
+          <a:solidFill>
+            <a:srgbClr val="2B579A"/>
+          </a:solidFill>
+          <a:ln>
+            <a:solidFill>
+              <a:srgbClr val="2B579A"/>
+            </a:solidFill>
+          </a:ln>
+        </p:spPr>
+        <p:style>
+          <a:lnRef idx="1">
+            <a:schemeClr val="accent1"/>
+          </a:lnRef>
+          <a:fillRef idx="3">
+            <a:schemeClr val="accent1"/>
+          </a:fillRef>
+          <a:effectRef idx="2">
+            <a:schemeClr val="accent1"/>
+          </a:effectRef>
+          <a:fontRef idx="minor">
+            <a:schemeClr val="lt1"/>
+          </a:fontRef>
+        </p:style>
+        <p:txBody>
+          <a:bodyPr rtlCol="0" anchor="ctr" wrap="square" tIns="0" bIns="0"/>
+          <a:lstStyle/>
+          <a:p>
+            <a:pPr algn="ctr"/>
+            <a:r>
+              <a:rPr sz="1300" b="1">
+                <a:solidFill>
+                  <a:srgbClr val="FFFFFF"/>
+                </a:solidFill>
+              </a:rPr>
+              <a:t>Plugins</a:t>
+            </a:r>
+          </a:p>
+        </p:txBody>
+      </p:sp>
+      <p:sp>
+        <p:nvSpPr>
+          <p:cNvPr id="9" name="Right Arrow 8"/>
+          <p:cNvSpPr/>
+          <p:nvPr/>
+        </p:nvSpPr>
+        <p:spPr>
+          <a:xfrm>
+            <a:off x="7115859" y="4937760"/>
+            <a:ext cx="274320" cy="310896"/>
+          </a:xfrm>
+          <a:prstGeom prst="rightArrow">
+            <a:avLst/>
+          </a:prstGeom>
+          <a:solidFill>
+            <a:srgbClr val="8A8A8A"/>
+          </a:solidFill>
+          <a:ln>
+            <a:noFill/>
+          </a:ln>
+        </p:spPr>
+        <p:style>
+          <a:lnRef idx="1">
+            <a:schemeClr val="accent1"/>
+          </a:lnRef>
+          <a:fillRef idx="3">
+            <a:schemeClr val="accent1"/>
+          </a:fillRef>
+          <a:effectRef idx="2">
+            <a:schemeClr val="accent1"/>
+          </a:effectRef>
+          <a:fontRef idx="minor">
+            <a:schemeClr val="lt1"/>
+          </a:fontRef>
+        </p:style>
+        <p:txBody>
+          <a:bodyPr rtlCol="0" anchor="ctr"/>
+          <a:lstStyle/>
+          <a:p>
+            <a:pPr algn="ctr"/>
+          </a:p>
+        </p:txBody>
+      </p:sp>
+      <p:sp>
+        <p:nvSpPr>
+          <p:cNvPr id="10" name="Rounded Rectangle 9"/>
+          <p:cNvSpPr/>
+          <p:nvPr/>
+        </p:nvSpPr>
+        <p:spPr>
+          <a:xfrm>
+            <a:off x="7445043" y="4572000"/>
+            <a:ext cx="1929993" cy="1051560"/>
+          </a:xfrm>
+          <a:prstGeom prst="roundRect">
+            <a:avLst/>
+          </a:prstGeom>
+          <a:solidFill>
+            <a:srgbClr val="2B579A"/>
+          </a:solidFill>
+          <a:ln>
+            <a:solidFill>
+              <a:srgbClr val="2B579A"/>
+            </a:solidFill>
+          </a:ln>
+        </p:spPr>
+        <p:style>
+          <a:lnRef idx="1">
+            <a:schemeClr val="accent1"/>
+          </a:lnRef>
+          <a:fillRef idx="3">
+            <a:schemeClr val="accent1"/>
+          </a:fillRef>
+          <a:effectRef idx="2">
+            <a:schemeClr val="accent1"/>
+          </a:effectRef>
+          <a:fontRef idx="minor">
+            <a:schemeClr val="lt1"/>
+          </a:fontRef>
+        </p:style>
+        <p:txBody>
+          <a:bodyPr rtlCol="0" anchor="ctr" wrap="square" tIns="0" bIns="0"/>
+          <a:lstStyle/>
+          <a:p>
+            <a:pPr algn="ctr"/>
+            <a:r>
+              <a:rPr sz="1300" b="1">
+                <a:solidFill>
+                  <a:srgbClr val="FFFFFF"/>
+                </a:solidFill>
+              </a:rPr>
+              <a:t>Admin-deployed</a:t>
+            </a:r>
+          </a:p>
+        </p:txBody>
+      </p:sp>
+      <p:sp>
+        <p:nvSpPr>
+          <p:cNvPr id="11" name="Right Arrow 10"/>
+          <p:cNvSpPr/>
+          <p:nvPr/>
+        </p:nvSpPr>
+        <p:spPr>
+          <a:xfrm>
+            <a:off x="9429900" y="4937760"/>
+            <a:ext cx="274320" cy="310896"/>
+          </a:xfrm>
+          <a:prstGeom prst="rightArrow">
+            <a:avLst/>
+          </a:prstGeom>
+          <a:solidFill>
+            <a:srgbClr val="8A8A8A"/>
+          </a:solidFill>
+          <a:ln>
+            <a:noFill/>
+          </a:ln>
+        </p:spPr>
+        <p:style>
+          <a:lnRef idx="1">
+            <a:schemeClr val="accent1"/>
+          </a:lnRef>
+          <a:fillRef idx="3">
+            <a:schemeClr val="accent1"/>
+          </a:fillRef>
+          <a:effectRef idx="2">
+            <a:schemeClr val="accent1"/>
+          </a:effectRef>
+          <a:fontRef idx="minor">
+            <a:schemeClr val="lt1"/>
+          </a:fontRef>
+        </p:style>
+        <p:txBody>
+          <a:bodyPr rtlCol="0" anchor="ctr"/>
+          <a:lstStyle/>
+          <a:p>
+            <a:pPr algn="ctr"/>
+          </a:p>
+        </p:txBody>
+      </p:sp>
+      <p:sp>
+        <p:nvSpPr>
+          <p:cNvPr id="12" name="Rounded Rectangle 11"/>
+          <p:cNvSpPr/>
+          <p:nvPr/>
+        </p:nvSpPr>
+        <p:spPr>
+          <a:xfrm>
+            <a:off x="9759084" y="4572000"/>
+            <a:ext cx="1929993" cy="1051560"/>
+          </a:xfrm>
+          <a:prstGeom prst="roundRect">
+            <a:avLst/>
+          </a:prstGeom>
+          <a:solidFill>
+            <a:srgbClr val="0F6C77"/>
+          </a:solidFill>
+          <a:ln>
+            <a:solidFill>
+              <a:srgbClr val="0F6C77"/>
+            </a:solidFill>
+          </a:ln>
+        </p:spPr>
+        <p:style>
+          <a:lnRef idx="1">
+            <a:schemeClr val="accent1"/>
+          </a:lnRef>
+          <a:fillRef idx="3">
+            <a:schemeClr val="accent1"/>
+          </a:fillRef>
+          <a:effectRef idx="2">
+            <a:schemeClr val="accent1"/>
+          </a:effectRef>
+          <a:fontRef idx="minor">
+            <a:schemeClr val="lt1"/>
+          </a:fontRef>
+        </p:style>
+        <p:txBody>
+          <a:bodyPr rtlCol="0" anchor="ctr" wrap="square" tIns="0" bIns="0"/>
+          <a:lstStyle/>
+          <a:p>
+            <a:pPr algn="ctr"/>
+            <a:r>
+              <a:rPr sz="1300" b="1">
+                <a:solidFill>
+                  <a:srgbClr val="FFFFFF"/>
+                </a:solidFill>
+              </a:rPr>
+              <a:t>Side panel</a:t>
             </a:r>
           </a:p>
         </p:txBody>
@@ -8377,8 +8814,8 @@
         </p:nvSpPr>
         <p:spPr>
           <a:xfrm>
-            <a:off x="257299" y="0"/>
-            <a:ext cx="11590317" cy="0"/>
+            <a:off x="457200" y="1417320"/>
+            <a:ext cx="11274552" cy="4754880"/>
           </a:xfrm>
         </p:spPr>
         <p:txBody>
@@ -8499,8 +8936,8 @@
         </p:nvSpPr>
         <p:spPr>
           <a:xfrm>
-            <a:off x="257299" y="0"/>
-            <a:ext cx="11590317" cy="0"/>
+            <a:off x="457200" y="1417320"/>
+            <a:ext cx="11274552" cy="4754880"/>
           </a:xfrm>
         </p:spPr>
         <p:txBody>
@@ -8695,8 +9132,8 @@
         </p:nvSpPr>
         <p:spPr>
           <a:xfrm>
-            <a:off x="257299" y="0"/>
-            <a:ext cx="11590317" cy="0"/>
+            <a:off x="457200" y="1417320"/>
+            <a:ext cx="11274552" cy="2743200"/>
           </a:xfrm>
         </p:spPr>
         <p:txBody>
@@ -8746,6 +9183,347 @@
             <a:r>
               <a:rPr lang="en-US" dirty="0"/>
               <a:t>Point a schedule at a custom skill: the skill is the how, the schedule the when</a:t>
+            </a:r>
+          </a:p>
+        </p:txBody>
+      </p:sp>
+      <p:sp>
+        <p:nvSpPr>
+          <p:cNvPr id="4" name="Rounded Rectangle 3"/>
+          <p:cNvSpPr/>
+          <p:nvPr/>
+        </p:nvSpPr>
+        <p:spPr>
+          <a:xfrm>
+            <a:off x="502920" y="4572000"/>
+            <a:ext cx="2508504" cy="1051560"/>
+          </a:xfrm>
+          <a:prstGeom prst="roundRect">
+            <a:avLst/>
+          </a:prstGeom>
+          <a:solidFill>
+            <a:srgbClr val="2B579A"/>
+          </a:solidFill>
+          <a:ln>
+            <a:solidFill>
+              <a:srgbClr val="2B579A"/>
+            </a:solidFill>
+          </a:ln>
+        </p:spPr>
+        <p:style>
+          <a:lnRef idx="1">
+            <a:schemeClr val="accent1"/>
+          </a:lnRef>
+          <a:fillRef idx="3">
+            <a:schemeClr val="accent1"/>
+          </a:fillRef>
+          <a:effectRef idx="2">
+            <a:schemeClr val="accent1"/>
+          </a:effectRef>
+          <a:fontRef idx="minor">
+            <a:schemeClr val="lt1"/>
+          </a:fontRef>
+        </p:style>
+        <p:txBody>
+          <a:bodyPr rtlCol="0" anchor="ctr" wrap="square" tIns="0" bIns="0"/>
+          <a:lstStyle/>
+          <a:p>
+            <a:pPr algn="ctr"/>
+            <a:r>
+              <a:rPr sz="1300" b="1">
+                <a:solidFill>
+                  <a:srgbClr val="FFFFFF"/>
+                </a:solidFill>
+              </a:rPr>
+              <a:t>Write the prompt</a:t>
+            </a:r>
+          </a:p>
+        </p:txBody>
+      </p:sp>
+      <p:sp>
+        <p:nvSpPr>
+          <p:cNvPr id="5" name="Right Arrow 4"/>
+          <p:cNvSpPr/>
+          <p:nvPr/>
+        </p:nvSpPr>
+        <p:spPr>
+          <a:xfrm>
+            <a:off x="3066288" y="4937760"/>
+            <a:ext cx="274320" cy="310896"/>
+          </a:xfrm>
+          <a:prstGeom prst="rightArrow">
+            <a:avLst/>
+          </a:prstGeom>
+          <a:solidFill>
+            <a:srgbClr val="8A8A8A"/>
+          </a:solidFill>
+          <a:ln>
+            <a:noFill/>
+          </a:ln>
+        </p:spPr>
+        <p:style>
+          <a:lnRef idx="1">
+            <a:schemeClr val="accent1"/>
+          </a:lnRef>
+          <a:fillRef idx="3">
+            <a:schemeClr val="accent1"/>
+          </a:fillRef>
+          <a:effectRef idx="2">
+            <a:schemeClr val="accent1"/>
+          </a:effectRef>
+          <a:fontRef idx="minor">
+            <a:schemeClr val="lt1"/>
+          </a:fontRef>
+        </p:style>
+        <p:txBody>
+          <a:bodyPr rtlCol="0" anchor="ctr"/>
+          <a:lstStyle/>
+          <a:p>
+            <a:pPr algn="ctr"/>
+          </a:p>
+        </p:txBody>
+      </p:sp>
+      <p:sp>
+        <p:nvSpPr>
+          <p:cNvPr id="6" name="Rounded Rectangle 5"/>
+          <p:cNvSpPr/>
+          <p:nvPr/>
+        </p:nvSpPr>
+        <p:spPr>
+          <a:xfrm>
+            <a:off x="3395472" y="4572000"/>
+            <a:ext cx="2508504" cy="1051560"/>
+          </a:xfrm>
+          <a:prstGeom prst="roundRect">
+            <a:avLst/>
+          </a:prstGeom>
+          <a:solidFill>
+            <a:srgbClr val="2B579A"/>
+          </a:solidFill>
+          <a:ln>
+            <a:solidFill>
+              <a:srgbClr val="2B579A"/>
+            </a:solidFill>
+          </a:ln>
+        </p:spPr>
+        <p:style>
+          <a:lnRef idx="1">
+            <a:schemeClr val="accent1"/>
+          </a:lnRef>
+          <a:fillRef idx="3">
+            <a:schemeClr val="accent1"/>
+          </a:fillRef>
+          <a:effectRef idx="2">
+            <a:schemeClr val="accent1"/>
+          </a:effectRef>
+          <a:fontRef idx="minor">
+            <a:schemeClr val="lt1"/>
+          </a:fontRef>
+        </p:style>
+        <p:txBody>
+          <a:bodyPr rtlCol="0" anchor="ctr" wrap="square" tIns="0" bIns="0"/>
+          <a:lstStyle/>
+          <a:p>
+            <a:pPr algn="ctr"/>
+            <a:r>
+              <a:rPr sz="1300" b="1">
+                <a:solidFill>
+                  <a:srgbClr val="FFFFFF"/>
+                </a:solidFill>
+              </a:rPr>
+              <a:t>Set a recurrence</a:t>
+            </a:r>
+          </a:p>
+        </p:txBody>
+      </p:sp>
+      <p:sp>
+        <p:nvSpPr>
+          <p:cNvPr id="7" name="Right Arrow 6"/>
+          <p:cNvSpPr/>
+          <p:nvPr/>
+        </p:nvSpPr>
+        <p:spPr>
+          <a:xfrm>
+            <a:off x="5958840" y="4937760"/>
+            <a:ext cx="274320" cy="310896"/>
+          </a:xfrm>
+          <a:prstGeom prst="rightArrow">
+            <a:avLst/>
+          </a:prstGeom>
+          <a:solidFill>
+            <a:srgbClr val="8A8A8A"/>
+          </a:solidFill>
+          <a:ln>
+            <a:noFill/>
+          </a:ln>
+        </p:spPr>
+        <p:style>
+          <a:lnRef idx="1">
+            <a:schemeClr val="accent1"/>
+          </a:lnRef>
+          <a:fillRef idx="3">
+            <a:schemeClr val="accent1"/>
+          </a:fillRef>
+          <a:effectRef idx="2">
+            <a:schemeClr val="accent1"/>
+          </a:effectRef>
+          <a:fontRef idx="minor">
+            <a:schemeClr val="lt1"/>
+          </a:fontRef>
+        </p:style>
+        <p:txBody>
+          <a:bodyPr rtlCol="0" anchor="ctr"/>
+          <a:lstStyle/>
+          <a:p>
+            <a:pPr algn="ctr"/>
+          </a:p>
+        </p:txBody>
+      </p:sp>
+      <p:sp>
+        <p:nvSpPr>
+          <p:cNvPr id="8" name="Rounded Rectangle 7"/>
+          <p:cNvSpPr/>
+          <p:nvPr/>
+        </p:nvSpPr>
+        <p:spPr>
+          <a:xfrm>
+            <a:off x="6288024" y="4572000"/>
+            <a:ext cx="2508504" cy="1051560"/>
+          </a:xfrm>
+          <a:prstGeom prst="roundRect">
+            <a:avLst/>
+          </a:prstGeom>
+          <a:solidFill>
+            <a:srgbClr val="2B579A"/>
+          </a:solidFill>
+          <a:ln>
+            <a:solidFill>
+              <a:srgbClr val="2B579A"/>
+            </a:solidFill>
+          </a:ln>
+        </p:spPr>
+        <p:style>
+          <a:lnRef idx="1">
+            <a:schemeClr val="accent1"/>
+          </a:lnRef>
+          <a:fillRef idx="3">
+            <a:schemeClr val="accent1"/>
+          </a:fillRef>
+          <a:effectRef idx="2">
+            <a:schemeClr val="accent1"/>
+          </a:effectRef>
+          <a:fontRef idx="minor">
+            <a:schemeClr val="lt1"/>
+          </a:fontRef>
+        </p:style>
+        <p:txBody>
+          <a:bodyPr rtlCol="0" anchor="ctr" wrap="square" tIns="0" bIns="0"/>
+          <a:lstStyle/>
+          <a:p>
+            <a:pPr algn="ctr"/>
+            <a:r>
+              <a:rPr sz="1300" b="1">
+                <a:solidFill>
+                  <a:srgbClr val="FFFFFF"/>
+                </a:solidFill>
+              </a:rPr>
+              <a:t>Cowork auto-runs</a:t>
+            </a:r>
+          </a:p>
+        </p:txBody>
+      </p:sp>
+      <p:sp>
+        <p:nvSpPr>
+          <p:cNvPr id="9" name="Right Arrow 8"/>
+          <p:cNvSpPr/>
+          <p:nvPr/>
+        </p:nvSpPr>
+        <p:spPr>
+          <a:xfrm>
+            <a:off x="8851392" y="4937760"/>
+            <a:ext cx="274320" cy="310896"/>
+          </a:xfrm>
+          <a:prstGeom prst="rightArrow">
+            <a:avLst/>
+          </a:prstGeom>
+          <a:solidFill>
+            <a:srgbClr val="8A8A8A"/>
+          </a:solidFill>
+          <a:ln>
+            <a:noFill/>
+          </a:ln>
+        </p:spPr>
+        <p:style>
+          <a:lnRef idx="1">
+            <a:schemeClr val="accent1"/>
+          </a:lnRef>
+          <a:fillRef idx="3">
+            <a:schemeClr val="accent1"/>
+          </a:fillRef>
+          <a:effectRef idx="2">
+            <a:schemeClr val="accent1"/>
+          </a:effectRef>
+          <a:fontRef idx="minor">
+            <a:schemeClr val="lt1"/>
+          </a:fontRef>
+        </p:style>
+        <p:txBody>
+          <a:bodyPr rtlCol="0" anchor="ctr"/>
+          <a:lstStyle/>
+          <a:p>
+            <a:pPr algn="ctr"/>
+          </a:p>
+        </p:txBody>
+      </p:sp>
+      <p:sp>
+        <p:nvSpPr>
+          <p:cNvPr id="10" name="Rounded Rectangle 9"/>
+          <p:cNvSpPr/>
+          <p:nvPr/>
+        </p:nvSpPr>
+        <p:spPr>
+          <a:xfrm>
+            <a:off x="9180576" y="4572000"/>
+            <a:ext cx="2508504" cy="1051560"/>
+          </a:xfrm>
+          <a:prstGeom prst="roundRect">
+            <a:avLst/>
+          </a:prstGeom>
+          <a:solidFill>
+            <a:srgbClr val="2B579A"/>
+          </a:solidFill>
+          <a:ln>
+            <a:solidFill>
+              <a:srgbClr val="2B579A"/>
+            </a:solidFill>
+          </a:ln>
+        </p:spPr>
+        <p:style>
+          <a:lnRef idx="1">
+            <a:schemeClr val="accent1"/>
+          </a:lnRef>
+          <a:fillRef idx="3">
+            <a:schemeClr val="accent1"/>
+          </a:fillRef>
+          <a:effectRef idx="2">
+            <a:schemeClr val="accent1"/>
+          </a:effectRef>
+          <a:fontRef idx="minor">
+            <a:schemeClr val="lt1"/>
+          </a:fontRef>
+        </p:style>
+        <p:txBody>
+          <a:bodyPr rtlCol="0" anchor="ctr" wrap="square" tIns="0" bIns="0"/>
+          <a:lstStyle/>
+          <a:p>
+            <a:pPr algn="ctr"/>
+            <a:r>
+              <a:rPr sz="1300" b="1">
+                <a:solidFill>
+                  <a:srgbClr val="FFFFFF"/>
+                </a:solidFill>
+              </a:rPr>
+              <a:t>Approve to send</a:t>
             </a:r>
           </a:p>
         </p:txBody>
@@ -8817,8 +9595,8 @@
         </p:nvSpPr>
         <p:spPr>
           <a:xfrm>
-            <a:off x="257299" y="0"/>
-            <a:ext cx="11590317" cy="0"/>
+            <a:off x="457200" y="1417320"/>
+            <a:ext cx="11274552" cy="4754880"/>
           </a:xfrm>
         </p:spPr>
         <p:txBody>
@@ -9013,8 +9791,8 @@
         </p:nvSpPr>
         <p:spPr>
           <a:xfrm>
-            <a:off x="257299" y="0"/>
-            <a:ext cx="11590317" cy="0"/>
+            <a:off x="457200" y="1417320"/>
+            <a:ext cx="11274552" cy="2743200"/>
           </a:xfrm>
         </p:spPr>
         <p:txBody>
@@ -9064,6 +9842,251 @@
             <a:r>
               <a:rPr lang="en-US" dirty="0"/>
               <a:t>Admins can deploy plugins organization-wide</a:t>
+            </a:r>
+          </a:p>
+        </p:txBody>
+      </p:sp>
+      <p:sp>
+        <p:nvSpPr>
+          <p:cNvPr id="4" name="Rounded Rectangle 3"/>
+          <p:cNvSpPr/>
+          <p:nvPr/>
+        </p:nvSpPr>
+        <p:spPr>
+          <a:xfrm>
+            <a:off x="502920" y="4572000"/>
+            <a:ext cx="3472688" cy="1051560"/>
+          </a:xfrm>
+          <a:prstGeom prst="roundRect">
+            <a:avLst/>
+          </a:prstGeom>
+          <a:solidFill>
+            <a:srgbClr val="2B579A"/>
+          </a:solidFill>
+          <a:ln>
+            <a:solidFill>
+              <a:srgbClr val="2B579A"/>
+            </a:solidFill>
+          </a:ln>
+        </p:spPr>
+        <p:style>
+          <a:lnRef idx="1">
+            <a:schemeClr val="accent1"/>
+          </a:lnRef>
+          <a:fillRef idx="3">
+            <a:schemeClr val="accent1"/>
+          </a:fillRef>
+          <a:effectRef idx="2">
+            <a:schemeClr val="accent1"/>
+          </a:effectRef>
+          <a:fontRef idx="minor">
+            <a:schemeClr val="lt1"/>
+          </a:fontRef>
+        </p:style>
+        <p:txBody>
+          <a:bodyPr rtlCol="0" anchor="ctr" wrap="square" tIns="0" bIns="0"/>
+          <a:lstStyle/>
+          <a:p>
+            <a:pPr algn="ctr"/>
+            <a:r>
+              <a:rPr sz="1300" b="1">
+                <a:solidFill>
+                  <a:srgbClr val="FFFFFF"/>
+                </a:solidFill>
+              </a:rPr>
+              <a:t>Marketplace plugin</a:t>
+            </a:r>
+          </a:p>
+        </p:txBody>
+      </p:sp>
+      <p:sp>
+        <p:nvSpPr>
+          <p:cNvPr id="5" name="Right Arrow 4"/>
+          <p:cNvSpPr/>
+          <p:nvPr/>
+        </p:nvSpPr>
+        <p:spPr>
+          <a:xfrm>
+            <a:off x="4030472" y="4937760"/>
+            <a:ext cx="274320" cy="310896"/>
+          </a:xfrm>
+          <a:prstGeom prst="rightArrow">
+            <a:avLst/>
+          </a:prstGeom>
+          <a:solidFill>
+            <a:srgbClr val="8A8A8A"/>
+          </a:solidFill>
+          <a:ln>
+            <a:noFill/>
+          </a:ln>
+        </p:spPr>
+        <p:style>
+          <a:lnRef idx="1">
+            <a:schemeClr val="accent1"/>
+          </a:lnRef>
+          <a:fillRef idx="3">
+            <a:schemeClr val="accent1"/>
+          </a:fillRef>
+          <a:effectRef idx="2">
+            <a:schemeClr val="accent1"/>
+          </a:effectRef>
+          <a:fontRef idx="minor">
+            <a:schemeClr val="lt1"/>
+          </a:fontRef>
+        </p:style>
+        <p:txBody>
+          <a:bodyPr rtlCol="0" anchor="ctr"/>
+          <a:lstStyle/>
+          <a:p>
+            <a:pPr algn="ctr"/>
+          </a:p>
+        </p:txBody>
+      </p:sp>
+      <p:sp>
+        <p:nvSpPr>
+          <p:cNvPr id="6" name="Rounded Rectangle 5"/>
+          <p:cNvSpPr/>
+          <p:nvPr/>
+        </p:nvSpPr>
+        <p:spPr>
+          <a:xfrm>
+            <a:off x="4359656" y="4572000"/>
+            <a:ext cx="3472688" cy="1051560"/>
+          </a:xfrm>
+          <a:prstGeom prst="roundRect">
+            <a:avLst/>
+          </a:prstGeom>
+          <a:solidFill>
+            <a:srgbClr val="2B579A"/>
+          </a:solidFill>
+          <a:ln>
+            <a:solidFill>
+              <a:srgbClr val="2B579A"/>
+            </a:solidFill>
+          </a:ln>
+        </p:spPr>
+        <p:style>
+          <a:lnRef idx="1">
+            <a:schemeClr val="accent1"/>
+          </a:lnRef>
+          <a:fillRef idx="3">
+            <a:schemeClr val="accent1"/>
+          </a:fillRef>
+          <a:effectRef idx="2">
+            <a:schemeClr val="accent1"/>
+          </a:effectRef>
+          <a:fontRef idx="minor">
+            <a:schemeClr val="lt1"/>
+          </a:fontRef>
+        </p:style>
+        <p:txBody>
+          <a:bodyPr rtlCol="0" anchor="ctr" wrap="square" tIns="0" bIns="0"/>
+          <a:lstStyle/>
+          <a:p>
+            <a:pPr algn="ctr"/>
+            <a:r>
+              <a:rPr sz="1300" b="1">
+                <a:solidFill>
+                  <a:srgbClr val="FFFFFF"/>
+                </a:solidFill>
+              </a:rPr>
+              <a:t>Skills + connectors</a:t>
+            </a:r>
+          </a:p>
+        </p:txBody>
+      </p:sp>
+      <p:sp>
+        <p:nvSpPr>
+          <p:cNvPr id="7" name="Right Arrow 6"/>
+          <p:cNvSpPr/>
+          <p:nvPr/>
+        </p:nvSpPr>
+        <p:spPr>
+          <a:xfrm>
+            <a:off x="7887208" y="4937760"/>
+            <a:ext cx="274320" cy="310896"/>
+          </a:xfrm>
+          <a:prstGeom prst="rightArrow">
+            <a:avLst/>
+          </a:prstGeom>
+          <a:solidFill>
+            <a:srgbClr val="8A8A8A"/>
+          </a:solidFill>
+          <a:ln>
+            <a:noFill/>
+          </a:ln>
+        </p:spPr>
+        <p:style>
+          <a:lnRef idx="1">
+            <a:schemeClr val="accent1"/>
+          </a:lnRef>
+          <a:fillRef idx="3">
+            <a:schemeClr val="accent1"/>
+          </a:fillRef>
+          <a:effectRef idx="2">
+            <a:schemeClr val="accent1"/>
+          </a:effectRef>
+          <a:fontRef idx="minor">
+            <a:schemeClr val="lt1"/>
+          </a:fontRef>
+        </p:style>
+        <p:txBody>
+          <a:bodyPr rtlCol="0" anchor="ctr"/>
+          <a:lstStyle/>
+          <a:p>
+            <a:pPr algn="ctr"/>
+          </a:p>
+        </p:txBody>
+      </p:sp>
+      <p:sp>
+        <p:nvSpPr>
+          <p:cNvPr id="8" name="Rounded Rectangle 7"/>
+          <p:cNvSpPr/>
+          <p:nvPr/>
+        </p:nvSpPr>
+        <p:spPr>
+          <a:xfrm>
+            <a:off x="8216392" y="4572000"/>
+            <a:ext cx="3472688" cy="1051560"/>
+          </a:xfrm>
+          <a:prstGeom prst="roundRect">
+            <a:avLst/>
+          </a:prstGeom>
+          <a:solidFill>
+            <a:srgbClr val="2B579A"/>
+          </a:solidFill>
+          <a:ln>
+            <a:solidFill>
+              <a:srgbClr val="2B579A"/>
+            </a:solidFill>
+          </a:ln>
+        </p:spPr>
+        <p:style>
+          <a:lnRef idx="1">
+            <a:schemeClr val="accent1"/>
+          </a:lnRef>
+          <a:fillRef idx="3">
+            <a:schemeClr val="accent1"/>
+          </a:fillRef>
+          <a:effectRef idx="2">
+            <a:schemeClr val="accent1"/>
+          </a:effectRef>
+          <a:fontRef idx="minor">
+            <a:schemeClr val="lt1"/>
+          </a:fontRef>
+        </p:style>
+        <p:txBody>
+          <a:bodyPr rtlCol="0" anchor="ctr" wrap="square" tIns="0" bIns="0"/>
+          <a:lstStyle/>
+          <a:p>
+            <a:pPr algn="ctr"/>
+            <a:r>
+              <a:rPr sz="1300" b="1">
+                <a:solidFill>
+                  <a:srgbClr val="FFFFFF"/>
+                </a:solidFill>
+              </a:rPr>
+              <a:t>Cowork</a:t>
             </a:r>
           </a:p>
         </p:txBody>
@@ -9135,8 +10158,8 @@
         </p:nvSpPr>
         <p:spPr>
           <a:xfrm>
-            <a:off x="257299" y="0"/>
-            <a:ext cx="11590317" cy="0"/>
+            <a:off x="457200" y="1417320"/>
+            <a:ext cx="11274552" cy="4754880"/>
           </a:xfrm>
         </p:spPr>
         <p:txBody>
@@ -10214,8 +11237,8 @@
         </p:nvSpPr>
         <p:spPr>
           <a:xfrm>
-            <a:off x="257299" y="0"/>
-            <a:ext cx="11590317" cy="0"/>
+            <a:off x="457200" y="1417320"/>
+            <a:ext cx="11274552" cy="2743200"/>
           </a:xfrm>
         </p:spPr>
         <p:txBody>
@@ -10265,6 +11288,198 @@
             <a:r>
               <a:rPr lang="en-US" dirty="0"/>
               <a:t>Allow similar actions for the rest of a session to skip repeat prompts</a:t>
+            </a:r>
+          </a:p>
+        </p:txBody>
+      </p:sp>
+      <p:sp>
+        <p:nvSpPr>
+          <p:cNvPr id="4" name="Rounded Rectangle 3"/>
+          <p:cNvSpPr/>
+          <p:nvPr/>
+        </p:nvSpPr>
+        <p:spPr>
+          <a:xfrm>
+            <a:off x="502920" y="4572000"/>
+            <a:ext cx="3618992" cy="1371600"/>
+          </a:xfrm>
+          <a:prstGeom prst="roundRect">
+            <a:avLst/>
+          </a:prstGeom>
+          <a:solidFill>
+            <a:srgbClr val="2E7D32"/>
+          </a:solidFill>
+          <a:ln>
+            <a:solidFill>
+              <a:srgbClr val="2E7D32"/>
+            </a:solidFill>
+          </a:ln>
+        </p:spPr>
+        <p:style>
+          <a:lnRef idx="1">
+            <a:schemeClr val="accent1"/>
+          </a:lnRef>
+          <a:fillRef idx="3">
+            <a:schemeClr val="accent1"/>
+          </a:fillRef>
+          <a:effectRef idx="2">
+            <a:schemeClr val="accent1"/>
+          </a:effectRef>
+          <a:fontRef idx="minor">
+            <a:schemeClr val="lt1"/>
+          </a:fontRef>
+        </p:style>
+        <p:txBody>
+          <a:bodyPr rtlCol="0" anchor="ctr" wrap="square" tIns="0" bIns="0"/>
+          <a:lstStyle/>
+          <a:p>
+            <a:pPr algn="ctr"/>
+            <a:r>
+              <a:rPr sz="1700" b="1">
+                <a:solidFill>
+                  <a:srgbClr val="FFFFFF"/>
+                </a:solidFill>
+              </a:rPr>
+              <a:t>Low</a:t>
+            </a:r>
+          </a:p>
+          <a:p>
+            <a:pPr algn="ctr"/>
+            <a:r>
+              <a:rPr sz="900">
+                <a:solidFill>
+                  <a:srgbClr val="FFFFFF"/>
+                </a:solidFill>
+              </a:rPr>
+              <a:t>Draft, search</a:t>
+            </a:r>
+          </a:p>
+        </p:txBody>
+      </p:sp>
+      <p:sp>
+        <p:nvSpPr>
+          <p:cNvPr id="5" name="Rounded Rectangle 4"/>
+          <p:cNvSpPr/>
+          <p:nvPr/>
+        </p:nvSpPr>
+        <p:spPr>
+          <a:xfrm>
+            <a:off x="4286504" y="4572000"/>
+            <a:ext cx="3618992" cy="1371600"/>
+          </a:xfrm>
+          <a:prstGeom prst="roundRect">
+            <a:avLst/>
+          </a:prstGeom>
+          <a:solidFill>
+            <a:srgbClr val="E68A00"/>
+          </a:solidFill>
+          <a:ln>
+            <a:solidFill>
+              <a:srgbClr val="E68A00"/>
+            </a:solidFill>
+          </a:ln>
+        </p:spPr>
+        <p:style>
+          <a:lnRef idx="1">
+            <a:schemeClr val="accent1"/>
+          </a:lnRef>
+          <a:fillRef idx="3">
+            <a:schemeClr val="accent1"/>
+          </a:fillRef>
+          <a:effectRef idx="2">
+            <a:schemeClr val="accent1"/>
+          </a:effectRef>
+          <a:fontRef idx="minor">
+            <a:schemeClr val="lt1"/>
+          </a:fontRef>
+        </p:style>
+        <p:txBody>
+          <a:bodyPr rtlCol="0" anchor="ctr" wrap="square" tIns="0" bIns="0"/>
+          <a:lstStyle/>
+          <a:p>
+            <a:pPr algn="ctr"/>
+            <a:r>
+              <a:rPr sz="1700" b="1">
+                <a:solidFill>
+                  <a:srgbClr val="202020"/>
+                </a:solidFill>
+              </a:rPr>
+              <a:t>Medium</a:t>
+            </a:r>
+          </a:p>
+          <a:p>
+            <a:pPr algn="ctr"/>
+            <a:r>
+              <a:rPr sz="900">
+                <a:solidFill>
+                  <a:srgbClr val="202020"/>
+                </a:solidFill>
+              </a:rPr>
+              <a:t>Save, schedule</a:t>
+            </a:r>
+          </a:p>
+        </p:txBody>
+      </p:sp>
+      <p:sp>
+        <p:nvSpPr>
+          <p:cNvPr id="6" name="Rounded Rectangle 5"/>
+          <p:cNvSpPr/>
+          <p:nvPr/>
+        </p:nvSpPr>
+        <p:spPr>
+          <a:xfrm>
+            <a:off x="8070088" y="4572000"/>
+            <a:ext cx="3618992" cy="1371600"/>
+          </a:xfrm>
+          <a:prstGeom prst="roundRect">
+            <a:avLst/>
+          </a:prstGeom>
+          <a:solidFill>
+            <a:srgbClr val="C62828"/>
+          </a:solidFill>
+          <a:ln>
+            <a:solidFill>
+              <a:srgbClr val="C62828"/>
+            </a:solidFill>
+          </a:ln>
+        </p:spPr>
+        <p:style>
+          <a:lnRef idx="1">
+            <a:schemeClr val="accent1"/>
+          </a:lnRef>
+          <a:fillRef idx="3">
+            <a:schemeClr val="accent1"/>
+          </a:fillRef>
+          <a:effectRef idx="2">
+            <a:schemeClr val="accent1"/>
+          </a:effectRef>
+          <a:fontRef idx="minor">
+            <a:schemeClr val="lt1"/>
+          </a:fontRef>
+        </p:style>
+        <p:txBody>
+          <a:bodyPr rtlCol="0" anchor="ctr" wrap="square" tIns="0" bIns="0"/>
+          <a:lstStyle/>
+          <a:p>
+            <a:pPr algn="ctr"/>
+            <a:r>
+              <a:rPr sz="1700" b="1">
+                <a:solidFill>
+                  <a:srgbClr val="FFFFFF"/>
+                </a:solidFill>
+              </a:rPr>
+              <a:t>High</a:t>
+            </a:r>
+          </a:p>
+          <a:p>
+            <a:pPr algn="ctr"/>
+            <a:r>
+              <a:rPr sz="900">
+                <a:solidFill>
+                  <a:srgbClr val="FFFFFF"/>
+                </a:solidFill>
+              </a:rPr>
+              <a:t>Send, post</a:t>
             </a:r>
           </a:p>
         </p:txBody>
@@ -10336,8 +11551,8 @@
         </p:nvSpPr>
         <p:spPr>
           <a:xfrm>
-            <a:off x="257299" y="0"/>
-            <a:ext cx="11590317" cy="0"/>
+            <a:off x="457200" y="1417320"/>
+            <a:ext cx="11274552" cy="4754880"/>
           </a:xfrm>
         </p:spPr>
         <p:txBody>
@@ -10763,8 +11978,8 @@
         </p:nvSpPr>
         <p:spPr>
           <a:xfrm>
-            <a:off x="257299" y="0"/>
-            <a:ext cx="11590317" cy="0"/>
+            <a:off x="457200" y="1417320"/>
+            <a:ext cx="11274552" cy="4754880"/>
           </a:xfrm>
         </p:spPr>
         <p:txBody>
@@ -10885,8 +12100,8 @@
         </p:nvSpPr>
         <p:spPr>
           <a:xfrm>
-            <a:off x="257299" y="0"/>
-            <a:ext cx="11590317" cy="0"/>
+            <a:off x="457200" y="1417320"/>
+            <a:ext cx="11274552" cy="4754880"/>
           </a:xfrm>
         </p:spPr>
         <p:txBody>
@@ -11007,8 +12222,8 @@
         </p:nvSpPr>
         <p:spPr>
           <a:xfrm>
-            <a:off x="257299" y="0"/>
-            <a:ext cx="11590317" cy="0"/>
+            <a:off x="457200" y="1417320"/>
+            <a:ext cx="11274552" cy="2743200"/>
           </a:xfrm>
         </p:spPr>
         <p:txBody>
@@ -11058,6 +12273,347 @@
             <a:r>
               <a:rPr lang="en-US" dirty="0"/>
               <a:t>It pauses for approval before sensitive actions, each marked with a risk level</a:t>
+            </a:r>
+          </a:p>
+        </p:txBody>
+      </p:sp>
+      <p:sp>
+        <p:nvSpPr>
+          <p:cNvPr id="4" name="Rounded Rectangle 3"/>
+          <p:cNvSpPr/>
+          <p:nvPr/>
+        </p:nvSpPr>
+        <p:spPr>
+          <a:xfrm>
+            <a:off x="502920" y="4572000"/>
+            <a:ext cx="2508504" cy="1051560"/>
+          </a:xfrm>
+          <a:prstGeom prst="roundRect">
+            <a:avLst/>
+          </a:prstGeom>
+          <a:solidFill>
+            <a:srgbClr val="2B579A"/>
+          </a:solidFill>
+          <a:ln>
+            <a:solidFill>
+              <a:srgbClr val="2B579A"/>
+            </a:solidFill>
+          </a:ln>
+        </p:spPr>
+        <p:style>
+          <a:lnRef idx="1">
+            <a:schemeClr val="accent1"/>
+          </a:lnRef>
+          <a:fillRef idx="3">
+            <a:schemeClr val="accent1"/>
+          </a:fillRef>
+          <a:effectRef idx="2">
+            <a:schemeClr val="accent1"/>
+          </a:effectRef>
+          <a:fontRef idx="minor">
+            <a:schemeClr val="lt1"/>
+          </a:fontRef>
+        </p:style>
+        <p:txBody>
+          <a:bodyPr rtlCol="0" anchor="ctr" wrap="square" tIns="0" bIns="0"/>
+          <a:lstStyle/>
+          <a:p>
+            <a:pPr algn="ctr"/>
+            <a:r>
+              <a:rPr sz="1300" b="1">
+                <a:solidFill>
+                  <a:srgbClr val="FFFFFF"/>
+                </a:solidFill>
+              </a:rPr>
+              <a:t>Describe the task</a:t>
+            </a:r>
+          </a:p>
+        </p:txBody>
+      </p:sp>
+      <p:sp>
+        <p:nvSpPr>
+          <p:cNvPr id="5" name="Right Arrow 4"/>
+          <p:cNvSpPr/>
+          <p:nvPr/>
+        </p:nvSpPr>
+        <p:spPr>
+          <a:xfrm>
+            <a:off x="3066288" y="4937760"/>
+            <a:ext cx="274320" cy="310896"/>
+          </a:xfrm>
+          <a:prstGeom prst="rightArrow">
+            <a:avLst/>
+          </a:prstGeom>
+          <a:solidFill>
+            <a:srgbClr val="8A8A8A"/>
+          </a:solidFill>
+          <a:ln>
+            <a:noFill/>
+          </a:ln>
+        </p:spPr>
+        <p:style>
+          <a:lnRef idx="1">
+            <a:schemeClr val="accent1"/>
+          </a:lnRef>
+          <a:fillRef idx="3">
+            <a:schemeClr val="accent1"/>
+          </a:fillRef>
+          <a:effectRef idx="2">
+            <a:schemeClr val="accent1"/>
+          </a:effectRef>
+          <a:fontRef idx="minor">
+            <a:schemeClr val="lt1"/>
+          </a:fontRef>
+        </p:style>
+        <p:txBody>
+          <a:bodyPr rtlCol="0" anchor="ctr"/>
+          <a:lstStyle/>
+          <a:p>
+            <a:pPr algn="ctr"/>
+          </a:p>
+        </p:txBody>
+      </p:sp>
+      <p:sp>
+        <p:nvSpPr>
+          <p:cNvPr id="6" name="Rounded Rectangle 5"/>
+          <p:cNvSpPr/>
+          <p:nvPr/>
+        </p:nvSpPr>
+        <p:spPr>
+          <a:xfrm>
+            <a:off x="3395472" y="4572000"/>
+            <a:ext cx="2508504" cy="1051560"/>
+          </a:xfrm>
+          <a:prstGeom prst="roundRect">
+            <a:avLst/>
+          </a:prstGeom>
+          <a:solidFill>
+            <a:srgbClr val="2B579A"/>
+          </a:solidFill>
+          <a:ln>
+            <a:solidFill>
+              <a:srgbClr val="2B579A"/>
+            </a:solidFill>
+          </a:ln>
+        </p:spPr>
+        <p:style>
+          <a:lnRef idx="1">
+            <a:schemeClr val="accent1"/>
+          </a:lnRef>
+          <a:fillRef idx="3">
+            <a:schemeClr val="accent1"/>
+          </a:fillRef>
+          <a:effectRef idx="2">
+            <a:schemeClr val="accent1"/>
+          </a:effectRef>
+          <a:fontRef idx="minor">
+            <a:schemeClr val="lt1"/>
+          </a:fontRef>
+        </p:style>
+        <p:txBody>
+          <a:bodyPr rtlCol="0" anchor="ctr" wrap="square" tIns="0" bIns="0"/>
+          <a:lstStyle/>
+          <a:p>
+            <a:pPr algn="ctr"/>
+            <a:r>
+              <a:rPr sz="1300" b="1">
+                <a:solidFill>
+                  <a:srgbClr val="FFFFFF"/>
+                </a:solidFill>
+              </a:rPr>
+              <a:t>Cowork works the steps</a:t>
+            </a:r>
+          </a:p>
+        </p:txBody>
+      </p:sp>
+      <p:sp>
+        <p:nvSpPr>
+          <p:cNvPr id="7" name="Right Arrow 6"/>
+          <p:cNvSpPr/>
+          <p:nvPr/>
+        </p:nvSpPr>
+        <p:spPr>
+          <a:xfrm>
+            <a:off x="5958840" y="4937760"/>
+            <a:ext cx="274320" cy="310896"/>
+          </a:xfrm>
+          <a:prstGeom prst="rightArrow">
+            <a:avLst/>
+          </a:prstGeom>
+          <a:solidFill>
+            <a:srgbClr val="8A8A8A"/>
+          </a:solidFill>
+          <a:ln>
+            <a:noFill/>
+          </a:ln>
+        </p:spPr>
+        <p:style>
+          <a:lnRef idx="1">
+            <a:schemeClr val="accent1"/>
+          </a:lnRef>
+          <a:fillRef idx="3">
+            <a:schemeClr val="accent1"/>
+          </a:fillRef>
+          <a:effectRef idx="2">
+            <a:schemeClr val="accent1"/>
+          </a:effectRef>
+          <a:fontRef idx="minor">
+            <a:schemeClr val="lt1"/>
+          </a:fontRef>
+        </p:style>
+        <p:txBody>
+          <a:bodyPr rtlCol="0" anchor="ctr"/>
+          <a:lstStyle/>
+          <a:p>
+            <a:pPr algn="ctr"/>
+          </a:p>
+        </p:txBody>
+      </p:sp>
+      <p:sp>
+        <p:nvSpPr>
+          <p:cNvPr id="8" name="Rounded Rectangle 7"/>
+          <p:cNvSpPr/>
+          <p:nvPr/>
+        </p:nvSpPr>
+        <p:spPr>
+          <a:xfrm>
+            <a:off x="6288024" y="4572000"/>
+            <a:ext cx="2508504" cy="1051560"/>
+          </a:xfrm>
+          <a:prstGeom prst="roundRect">
+            <a:avLst/>
+          </a:prstGeom>
+          <a:solidFill>
+            <a:srgbClr val="2B579A"/>
+          </a:solidFill>
+          <a:ln>
+            <a:solidFill>
+              <a:srgbClr val="2B579A"/>
+            </a:solidFill>
+          </a:ln>
+        </p:spPr>
+        <p:style>
+          <a:lnRef idx="1">
+            <a:schemeClr val="accent1"/>
+          </a:lnRef>
+          <a:fillRef idx="3">
+            <a:schemeClr val="accent1"/>
+          </a:fillRef>
+          <a:effectRef idx="2">
+            <a:schemeClr val="accent1"/>
+          </a:effectRef>
+          <a:fontRef idx="minor">
+            <a:schemeClr val="lt1"/>
+          </a:fontRef>
+        </p:style>
+        <p:txBody>
+          <a:bodyPr rtlCol="0" anchor="ctr" wrap="square" tIns="0" bIns="0"/>
+          <a:lstStyle/>
+          <a:p>
+            <a:pPr algn="ctr"/>
+            <a:r>
+              <a:rPr sz="1300" b="1">
+                <a:solidFill>
+                  <a:srgbClr val="FFFFFF"/>
+                </a:solidFill>
+              </a:rPr>
+              <a:t>Approve sensitive actions</a:t>
+            </a:r>
+          </a:p>
+        </p:txBody>
+      </p:sp>
+      <p:sp>
+        <p:nvSpPr>
+          <p:cNvPr id="9" name="Right Arrow 8"/>
+          <p:cNvSpPr/>
+          <p:nvPr/>
+        </p:nvSpPr>
+        <p:spPr>
+          <a:xfrm>
+            <a:off x="8851392" y="4937760"/>
+            <a:ext cx="274320" cy="310896"/>
+          </a:xfrm>
+          <a:prstGeom prst="rightArrow">
+            <a:avLst/>
+          </a:prstGeom>
+          <a:solidFill>
+            <a:srgbClr val="8A8A8A"/>
+          </a:solidFill>
+          <a:ln>
+            <a:noFill/>
+          </a:ln>
+        </p:spPr>
+        <p:style>
+          <a:lnRef idx="1">
+            <a:schemeClr val="accent1"/>
+          </a:lnRef>
+          <a:fillRef idx="3">
+            <a:schemeClr val="accent1"/>
+          </a:fillRef>
+          <a:effectRef idx="2">
+            <a:schemeClr val="accent1"/>
+          </a:effectRef>
+          <a:fontRef idx="minor">
+            <a:schemeClr val="lt1"/>
+          </a:fontRef>
+        </p:style>
+        <p:txBody>
+          <a:bodyPr rtlCol="0" anchor="ctr"/>
+          <a:lstStyle/>
+          <a:p>
+            <a:pPr algn="ctr"/>
+          </a:p>
+        </p:txBody>
+      </p:sp>
+      <p:sp>
+        <p:nvSpPr>
+          <p:cNvPr id="10" name="Rounded Rectangle 9"/>
+          <p:cNvSpPr/>
+          <p:nvPr/>
+        </p:nvSpPr>
+        <p:spPr>
+          <a:xfrm>
+            <a:off x="9180576" y="4572000"/>
+            <a:ext cx="2508504" cy="1051560"/>
+          </a:xfrm>
+          <a:prstGeom prst="roundRect">
+            <a:avLst/>
+          </a:prstGeom>
+          <a:solidFill>
+            <a:srgbClr val="2B579A"/>
+          </a:solidFill>
+          <a:ln>
+            <a:solidFill>
+              <a:srgbClr val="2B579A"/>
+            </a:solidFill>
+          </a:ln>
+        </p:spPr>
+        <p:style>
+          <a:lnRef idx="1">
+            <a:schemeClr val="accent1"/>
+          </a:lnRef>
+          <a:fillRef idx="3">
+            <a:schemeClr val="accent1"/>
+          </a:fillRef>
+          <a:effectRef idx="2">
+            <a:schemeClr val="accent1"/>
+          </a:effectRef>
+          <a:fontRef idx="minor">
+            <a:schemeClr val="lt1"/>
+          </a:fontRef>
+        </p:style>
+        <p:txBody>
+          <a:bodyPr rtlCol="0" anchor="ctr" wrap="square" tIns="0" bIns="0"/>
+          <a:lstStyle/>
+          <a:p>
+            <a:pPr algn="ctr"/>
+            <a:r>
+              <a:rPr sz="1300" b="1">
+                <a:solidFill>
+                  <a:srgbClr val="FFFFFF"/>
+                </a:solidFill>
+              </a:rPr>
+              <a:t>Review the result</a:t>
             </a:r>
           </a:p>
         </p:txBody>
@@ -11203,8 +12759,8 @@
         </p:nvSpPr>
         <p:spPr>
           <a:xfrm>
-            <a:off x="257299" y="0"/>
-            <a:ext cx="11590317" cy="0"/>
+            <a:off x="457200" y="1417320"/>
+            <a:ext cx="11274552" cy="4754880"/>
           </a:xfrm>
         </p:spPr>
         <p:txBody>

</xml_diff>